<commit_message>
update 8 - 10
</commit_message>
<xml_diff>
--- a/topic08-higher-order-functions/unit-08a-lectures/talk-2/b-function-appl.pptx
+++ b/topic08-higher-order-functions/unit-08a-lectures/talk-2/b-function-appl.pptx
@@ -525,10 +525,10 @@
           </a:ln>
           <a:extLst>
             <a:ext uri="{FAA26D3D-D897-4be2-8F04-BA451C77F1D7}">
-              <ma14:placeholderFlag xmlns="" xmlns:ma14="http://schemas.microsoft.com/office/mac/drawingml/2011/main" val="1"/>
+              <ma14:placeholderFlag xmlns:ma14="http://schemas.microsoft.com/office/mac/drawingml/2011/main" xmlns="" val="1"/>
             </a:ext>
             <a:ext uri="{909E8E84-426E-40dd-AFC4-6F175D3DCCD1}">
-              <a14:hiddenFill xmlns="" xmlns:a14="http://schemas.microsoft.com/office/drawing/2010/main">
+              <a14:hiddenFill xmlns:a14="http://schemas.microsoft.com/office/drawing/2010/main" xmlns="">
                 <a:solidFill>
                   <a:srgbClr val="FFFFFF"/>
                 </a:solidFill>
@@ -1110,7 +1110,7 @@
             <a:fld id="{08B9EBBA-996F-894A-B54A-D6246ED52CEA}" type="datetimeFigureOut">
               <a:rPr lang="en-US" smtClean="0"/>
               <a:pPr/>
-              <a:t>3/7/26</a:t>
+              <a:t>3/9/26</a:t>
             </a:fld>
             <a:endParaRPr lang="en-US" dirty="0"/>
           </a:p>
@@ -1532,7 +1532,7 @@
             <a:fld id="{09B482E8-6E0E-1B4F-B1FD-C69DB9E858D9}" type="datetimeFigureOut">
               <a:rPr lang="en-US" smtClean="0"/>
               <a:pPr/>
-              <a:t>3/7/26</a:t>
+              <a:t>3/9/26</a:t>
             </a:fld>
             <a:endParaRPr lang="en-US" dirty="0"/>
           </a:p>
@@ -1876,7 +1876,7 @@
             <a:fld id="{09B482E8-6E0E-1B4F-B1FD-C69DB9E858D9}" type="datetimeFigureOut">
               <a:rPr lang="en-US" smtClean="0"/>
               <a:pPr/>
-              <a:t>3/7/26</a:t>
+              <a:t>3/9/26</a:t>
             </a:fld>
             <a:endParaRPr lang="en-US" dirty="0"/>
           </a:p>
@@ -2289,7 +2289,7 @@
             <a:fld id="{09B482E8-6E0E-1B4F-B1FD-C69DB9E858D9}" type="datetimeFigureOut">
               <a:rPr lang="en-US" smtClean="0"/>
               <a:pPr/>
-              <a:t>3/7/26</a:t>
+              <a:t>3/9/26</a:t>
             </a:fld>
             <a:endParaRPr lang="en-US" dirty="0"/>
           </a:p>
@@ -2865,7 +2865,7 @@
             <a:fld id="{09B482E8-6E0E-1B4F-B1FD-C69DB9E858D9}" type="datetimeFigureOut">
               <a:rPr lang="en-US" smtClean="0"/>
               <a:pPr/>
-              <a:t>3/7/26</a:t>
+              <a:t>3/9/26</a:t>
             </a:fld>
             <a:endParaRPr lang="en-US" dirty="0"/>
           </a:p>
@@ -3554,7 +3554,7 @@
             <a:fld id="{09B482E8-6E0E-1B4F-B1FD-C69DB9E858D9}" type="datetimeFigureOut">
               <a:rPr lang="en-US" smtClean="0"/>
               <a:pPr/>
-              <a:t>3/7/26</a:t>
+              <a:t>3/9/26</a:t>
             </a:fld>
             <a:endParaRPr lang="en-US" dirty="0"/>
           </a:p>
@@ -4475,7 +4475,7 @@
             <a:fld id="{09B482E8-6E0E-1B4F-B1FD-C69DB9E858D9}" type="datetimeFigureOut">
               <a:rPr lang="en-US" smtClean="0"/>
               <a:pPr/>
-              <a:t>3/7/26</a:t>
+              <a:t>3/9/26</a:t>
             </a:fld>
             <a:endParaRPr lang="en-US" dirty="0"/>
           </a:p>
@@ -4796,7 +4796,7 @@
             <a:fld id="{09B482E8-6E0E-1B4F-B1FD-C69DB9E858D9}" type="datetimeFigureOut">
               <a:rPr lang="en-US" smtClean="0"/>
               <a:pPr/>
-              <a:t>3/7/26</a:t>
+              <a:t>3/9/26</a:t>
             </a:fld>
             <a:endParaRPr lang="en-US" dirty="0"/>
           </a:p>
@@ -5067,7 +5067,7 @@
             <a:fld id="{09B482E8-6E0E-1B4F-B1FD-C69DB9E858D9}" type="datetimeFigureOut">
               <a:rPr lang="en-US" smtClean="0"/>
               <a:pPr/>
-              <a:t>3/7/26</a:t>
+              <a:t>3/9/26</a:t>
             </a:fld>
             <a:endParaRPr lang="en-US" dirty="0"/>
           </a:p>
@@ -5411,7 +5411,7 @@
             <a:fld id="{09B482E8-6E0E-1B4F-B1FD-C69DB9E858D9}" type="datetimeFigureOut">
               <a:rPr lang="en-US" smtClean="0"/>
               <a:pPr/>
-              <a:t>3/7/26</a:t>
+              <a:t>3/9/26</a:t>
             </a:fld>
             <a:endParaRPr lang="en-US" dirty="0"/>
           </a:p>
@@ -5807,7 +5807,7 @@
             <a:fld id="{8DFA1846-DA80-1C48-A609-854EA85C59AD}" type="datetimeFigureOut">
               <a:rPr lang="en-US" smtClean="0"/>
               <a:pPr/>
-              <a:t>3/7/26</a:t>
+              <a:t>3/9/26</a:t>
             </a:fld>
             <a:endParaRPr lang="en-US" dirty="0"/>
           </a:p>
@@ -6190,7 +6190,7 @@
             <a:fld id="{09B482E8-6E0E-1B4F-B1FD-C69DB9E858D9}" type="datetimeFigureOut">
               <a:rPr lang="en-US" smtClean="0"/>
               <a:pPr/>
-              <a:t>3/7/26</a:t>
+              <a:t>3/9/26</a:t>
             </a:fld>
             <a:endParaRPr lang="en-US" dirty="0"/>
           </a:p>
@@ -6703,7 +6703,7 @@
             <a:fld id="{09B482E8-6E0E-1B4F-B1FD-C69DB9E858D9}" type="datetimeFigureOut">
               <a:rPr lang="en-US" smtClean="0"/>
               <a:pPr/>
-              <a:t>3/7/26</a:t>
+              <a:t>3/9/26</a:t>
             </a:fld>
             <a:endParaRPr lang="en-US" dirty="0"/>
           </a:p>
@@ -6981,7 +6981,7 @@
             <a:fld id="{F13A34C8-038E-2045-AF43-DF7DBB8E0E9E}" type="datetimeFigureOut">
               <a:rPr lang="en-US" smtClean="0"/>
               <a:pPr/>
-              <a:t>3/7/26</a:t>
+              <a:t>3/9/26</a:t>
             </a:fld>
             <a:endParaRPr lang="en-US" dirty="0"/>
           </a:p>
@@ -7158,7 +7158,7 @@
             <a:fld id="{8818C68F-D26B-8F47-958C-23B49CF8A634}" type="datetimeFigureOut">
               <a:rPr lang="en-US" smtClean="0"/>
               <a:pPr/>
-              <a:t>3/7/26</a:t>
+              <a:t>3/9/26</a:t>
             </a:fld>
             <a:endParaRPr lang="en-US" dirty="0"/>
           </a:p>
@@ -7555,7 +7555,7 @@
             <a:fld id="{09B482E8-6E0E-1B4F-B1FD-C69DB9E858D9}" type="datetimeFigureOut">
               <a:rPr lang="en-US" smtClean="0"/>
               <a:pPr/>
-              <a:t>3/7/26</a:t>
+              <a:t>3/9/26</a:t>
             </a:fld>
             <a:endParaRPr lang="en-US" dirty="0"/>
           </a:p>
@@ -7971,7 +7971,7 @@
             <a:fld id="{09B482E8-6E0E-1B4F-B1FD-C69DB9E858D9}" type="datetimeFigureOut">
               <a:rPr lang="en-US" smtClean="0"/>
               <a:pPr/>
-              <a:t>3/7/26</a:t>
+              <a:t>3/9/26</a:t>
             </a:fld>
             <a:endParaRPr lang="en-US" dirty="0"/>
           </a:p>
@@ -8222,7 +8222,7 @@
             <a:fld id="{09B482E8-6E0E-1B4F-B1FD-C69DB9E858D9}" type="datetimeFigureOut">
               <a:rPr lang="en-US" smtClean="0"/>
               <a:pPr/>
-              <a:t>3/7/26</a:t>
+              <a:t>3/9/26</a:t>
             </a:fld>
             <a:endParaRPr lang="en-US" dirty="0"/>
           </a:p>
@@ -8659,14 +8659,14 @@
           <a:noFill/>
           <a:extLst>
             <a:ext uri="{909E8E84-426E-40dd-AFC4-6F175D3DCCD1}">
-              <a14:hiddenFill xmlns="" xmlns:a14="http://schemas.microsoft.com/office/drawing/2010/main">
+              <a14:hiddenFill xmlns:a14="http://schemas.microsoft.com/office/drawing/2010/main" xmlns="">
                 <a:solidFill>
                   <a:srgbClr val="FFFFFF"/>
                 </a:solidFill>
               </a14:hiddenFill>
             </a:ext>
             <a:ext uri="{91240B29-F687-4f45-9708-019B960494DF}">
-              <a14:hiddenLine xmlns="" xmlns:a14="http://schemas.microsoft.com/office/drawing/2010/main" w="9525">
+              <a14:hiddenLine xmlns:a14="http://schemas.microsoft.com/office/drawing/2010/main" xmlns="" w="9525">
                 <a:solidFill>
                   <a:srgbClr val="000000"/>
                 </a:solidFill>
@@ -8914,14 +8914,14 @@
           </a:ln>
           <a:extLst>
             <a:ext uri="{909E8E84-426E-40dd-AFC4-6F175D3DCCD1}">
-              <a14:hiddenFill xmlns="" xmlns:a14="http://schemas.microsoft.com/office/drawing/2010/main">
+              <a14:hiddenFill xmlns:a14="http://schemas.microsoft.com/office/drawing/2010/main" xmlns="">
                 <a:solidFill>
                   <a:srgbClr val="FFFFFF"/>
                 </a:solidFill>
               </a14:hiddenFill>
             </a:ext>
             <a:ext uri="{91240B29-F687-4f45-9708-019B960494DF}">
-              <a14:hiddenLine xmlns="" xmlns:a14="http://schemas.microsoft.com/office/drawing/2010/main" w="9525">
+              <a14:hiddenLine xmlns:a14="http://schemas.microsoft.com/office/drawing/2010/main" xmlns="" w="9525">
                 <a:solidFill>
                   <a:srgbClr val="000000"/>
                 </a:solidFill>
@@ -9003,14 +9003,14 @@
           <a:noFill/>
           <a:extLst>
             <a:ext uri="{909E8E84-426E-40dd-AFC4-6F175D3DCCD1}">
-              <a14:hiddenFill xmlns="" xmlns:a14="http://schemas.microsoft.com/office/drawing/2010/main">
+              <a14:hiddenFill xmlns:a14="http://schemas.microsoft.com/office/drawing/2010/main" xmlns="">
                 <a:solidFill>
                   <a:srgbClr val="FFFFFF"/>
                 </a:solidFill>
               </a14:hiddenFill>
             </a:ext>
             <a:ext uri="{91240B29-F687-4f45-9708-019B960494DF}">
-              <a14:hiddenLine xmlns="" xmlns:a14="http://schemas.microsoft.com/office/drawing/2010/main" w="9525">
+              <a14:hiddenLine xmlns:a14="http://schemas.microsoft.com/office/drawing/2010/main" xmlns="" w="9525">
                 <a:solidFill>
                   <a:srgbClr val="000000"/>
                 </a:solidFill>
@@ -9230,7 +9230,7 @@
           </a:ln>
           <a:extLst>
             <a:ext uri="{91240B29-F687-4f45-9708-019B960494DF}">
-              <a14:hiddenLine xmlns:a14="http://schemas.microsoft.com/office/drawing/2010/main" xmlns="" w="12700" cap="sq">
+              <a14:hiddenLine xmlns="" xmlns:a14="http://schemas.microsoft.com/office/drawing/2010/main" w="12700" cap="sq">
                 <a:solidFill>
                   <a:srgbClr val="000000"/>
                 </a:solidFill>
@@ -9745,14 +9745,14 @@
           <a:noFill/>
           <a:extLst>
             <a:ext uri="{909E8E84-426E-40dd-AFC4-6F175D3DCCD1}">
-              <a14:hiddenFill xmlns="" xmlns:a14="http://schemas.microsoft.com/office/drawing/2010/main">
+              <a14:hiddenFill xmlns:a14="http://schemas.microsoft.com/office/drawing/2010/main" xmlns="">
                 <a:solidFill>
                   <a:srgbClr val="FFFFFF"/>
                 </a:solidFill>
               </a14:hiddenFill>
             </a:ext>
             <a:ext uri="{91240B29-F687-4f45-9708-019B960494DF}">
-              <a14:hiddenLine xmlns="" xmlns:a14="http://schemas.microsoft.com/office/drawing/2010/main" w="9525">
+              <a14:hiddenLine xmlns:a14="http://schemas.microsoft.com/office/drawing/2010/main" xmlns="" w="9525">
                 <a:solidFill>
                   <a:srgbClr val="000000"/>
                 </a:solidFill>
@@ -10574,14 +10574,14 @@
           <a:noFill/>
           <a:extLst>
             <a:ext uri="{909E8E84-426E-40dd-AFC4-6F175D3DCCD1}">
-              <a14:hiddenFill xmlns="" xmlns:a14="http://schemas.microsoft.com/office/drawing/2010/main">
+              <a14:hiddenFill xmlns:a14="http://schemas.microsoft.com/office/drawing/2010/main" xmlns="">
                 <a:solidFill>
                   <a:srgbClr val="FFFFFF"/>
                 </a:solidFill>
               </a14:hiddenFill>
             </a:ext>
             <a:ext uri="{91240B29-F687-4f45-9708-019B960494DF}">
-              <a14:hiddenLine xmlns="" xmlns:a14="http://schemas.microsoft.com/office/drawing/2010/main" w="9525">
+              <a14:hiddenLine xmlns:a14="http://schemas.microsoft.com/office/drawing/2010/main" xmlns="" w="9525">
                 <a:solidFill>
                   <a:srgbClr val="000000"/>
                 </a:solidFill>
@@ -11221,14 +11221,14 @@
           <a:noFill/>
           <a:extLst>
             <a:ext uri="{909E8E84-426E-40dd-AFC4-6F175D3DCCD1}">
-              <a14:hiddenFill xmlns="" xmlns:a14="http://schemas.microsoft.com/office/drawing/2010/main">
+              <a14:hiddenFill xmlns:a14="http://schemas.microsoft.com/office/drawing/2010/main" xmlns="">
                 <a:solidFill>
                   <a:srgbClr val="FFFFFF"/>
                 </a:solidFill>
               </a14:hiddenFill>
             </a:ext>
             <a:ext uri="{91240B29-F687-4f45-9708-019B960494DF}">
-              <a14:hiddenLine xmlns="" xmlns:a14="http://schemas.microsoft.com/office/drawing/2010/main" w="9525">
+              <a14:hiddenLine xmlns:a14="http://schemas.microsoft.com/office/drawing/2010/main" xmlns="" w="9525">
                 <a:solidFill>
                   <a:srgbClr val="000000"/>
                 </a:solidFill>
@@ -11643,7 +11643,7 @@
           </a:ln>
           <a:extLst>
             <a:ext uri="{91240B29-F687-4f45-9708-019B960494DF}">
-              <a14:hiddenLine xmlns:a14="http://schemas.microsoft.com/office/drawing/2010/main" xmlns="" w="12700" cap="sq">
+              <a14:hiddenLine xmlns="" xmlns:a14="http://schemas.microsoft.com/office/drawing/2010/main" w="12700" cap="sq">
                 <a:solidFill>
                   <a:srgbClr val="000000"/>
                 </a:solidFill>
@@ -11804,7 +11804,7 @@
           </a:ln>
           <a:extLst>
             <a:ext uri="{91240B29-F687-4f45-9708-019B960494DF}">
-              <a14:hiddenLine xmlns:a14="http://schemas.microsoft.com/office/drawing/2010/main" xmlns="" w="12700" cap="sq">
+              <a14:hiddenLine xmlns="" xmlns:a14="http://schemas.microsoft.com/office/drawing/2010/main" w="12700" cap="sq">
                 <a:solidFill>
                   <a:srgbClr val="000000"/>
                 </a:solidFill>
@@ -12396,14 +12396,14 @@
           <a:noFill/>
           <a:extLst>
             <a:ext uri="{909E8E84-426E-40dd-AFC4-6F175D3DCCD1}">
-              <a14:hiddenFill xmlns="" xmlns:a14="http://schemas.microsoft.com/office/drawing/2010/main">
+              <a14:hiddenFill xmlns:a14="http://schemas.microsoft.com/office/drawing/2010/main" xmlns="">
                 <a:solidFill>
                   <a:srgbClr val="FFFFFF"/>
                 </a:solidFill>
               </a14:hiddenFill>
             </a:ext>
             <a:ext uri="{91240B29-F687-4f45-9708-019B960494DF}">
-              <a14:hiddenLine xmlns="" xmlns:a14="http://schemas.microsoft.com/office/drawing/2010/main" w="9525">
+              <a14:hiddenLine xmlns:a14="http://schemas.microsoft.com/office/drawing/2010/main" xmlns="" w="9525">
                 <a:solidFill>
                   <a:srgbClr val="000000"/>
                 </a:solidFill>
@@ -12815,7 +12815,7 @@
           </a:ln>
           <a:extLst>
             <a:ext uri="{91240B29-F687-4f45-9708-019B960494DF}">
-              <a14:hiddenLine xmlns:a14="http://schemas.microsoft.com/office/drawing/2010/main" xmlns="" w="12700" cap="sq">
+              <a14:hiddenLine xmlns="" xmlns:a14="http://schemas.microsoft.com/office/drawing/2010/main" w="12700" cap="sq">
                 <a:solidFill>
                   <a:srgbClr val="000000"/>
                 </a:solidFill>
@@ -12976,7 +12976,7 @@
           </a:ln>
           <a:extLst>
             <a:ext uri="{91240B29-F687-4f45-9708-019B960494DF}">
-              <a14:hiddenLine xmlns:a14="http://schemas.microsoft.com/office/drawing/2010/main" xmlns="" w="12700" cap="sq">
+              <a14:hiddenLine xmlns="" xmlns:a14="http://schemas.microsoft.com/office/drawing/2010/main" w="12700" cap="sq">
                 <a:solidFill>
                   <a:srgbClr val="000000"/>
                 </a:solidFill>
@@ -13142,14 +13142,14 @@
           <a:effectLst/>
           <a:extLst>
             <a:ext uri="{909E8E84-426E-40dd-AFC4-6F175D3DCCD1}">
-              <a14:hiddenFill xmlns:a14="http://schemas.microsoft.com/office/drawing/2010/main" xmlns="">
+              <a14:hiddenFill xmlns="" xmlns:a14="http://schemas.microsoft.com/office/drawing/2010/main">
                 <a:solidFill>
                   <a:schemeClr val="accent1"/>
                 </a:solidFill>
               </a14:hiddenFill>
             </a:ext>
             <a:ext uri="{AF507438-7753-43e0-B8FC-AC1667EBCBE1}">
-              <a14:hiddenEffects xmlns:a14="http://schemas.microsoft.com/office/drawing/2010/main" xmlns="">
+              <a14:hiddenEffects xmlns="" xmlns:a14="http://schemas.microsoft.com/office/drawing/2010/main">
                 <a:effectLst>
                   <a:outerShdw blurRad="63500" dist="35921" dir="2700000" algn="ctr" rotWithShape="0">
                     <a:schemeClr val="bg2"/>
@@ -13190,7 +13190,7 @@
           </a:ln>
           <a:extLst>
             <a:ext uri="{91240B29-F687-4f45-9708-019B960494DF}">
-              <a14:hiddenLine xmlns:a14="http://schemas.microsoft.com/office/drawing/2010/main" xmlns="" w="12700" cap="sq">
+              <a14:hiddenLine xmlns="" xmlns:a14="http://schemas.microsoft.com/office/drawing/2010/main" w="12700" cap="sq">
                 <a:solidFill>
                   <a:srgbClr val="000000"/>
                 </a:solidFill>
@@ -13351,7 +13351,7 @@
           </a:ln>
           <a:extLst>
             <a:ext uri="{91240B29-F687-4f45-9708-019B960494DF}">
-              <a14:hiddenLine xmlns:a14="http://schemas.microsoft.com/office/drawing/2010/main" xmlns="" w="12700" cap="sq">
+              <a14:hiddenLine xmlns="" xmlns:a14="http://schemas.microsoft.com/office/drawing/2010/main" w="12700" cap="sq">
                 <a:solidFill>
                   <a:srgbClr val="000000"/>
                 </a:solidFill>
@@ -13512,7 +13512,7 @@
           </a:ln>
           <a:extLst>
             <a:ext uri="{91240B29-F687-4f45-9708-019B960494DF}">
-              <a14:hiddenLine xmlns:a14="http://schemas.microsoft.com/office/drawing/2010/main" xmlns="" w="12700" cap="sq">
+              <a14:hiddenLine xmlns="" xmlns:a14="http://schemas.microsoft.com/office/drawing/2010/main" w="12700" cap="sq">
                 <a:solidFill>
                   <a:srgbClr val="000000"/>
                 </a:solidFill>
@@ -13678,14 +13678,14 @@
           <a:effectLst/>
           <a:extLst>
             <a:ext uri="{909E8E84-426E-40dd-AFC4-6F175D3DCCD1}">
-              <a14:hiddenFill xmlns:a14="http://schemas.microsoft.com/office/drawing/2010/main" xmlns="">
+              <a14:hiddenFill xmlns="" xmlns:a14="http://schemas.microsoft.com/office/drawing/2010/main">
                 <a:solidFill>
                   <a:schemeClr val="accent1"/>
                 </a:solidFill>
               </a14:hiddenFill>
             </a:ext>
             <a:ext uri="{AF507438-7753-43e0-B8FC-AC1667EBCBE1}">
-              <a14:hiddenEffects xmlns:a14="http://schemas.microsoft.com/office/drawing/2010/main" xmlns="">
+              <a14:hiddenEffects xmlns="" xmlns:a14="http://schemas.microsoft.com/office/drawing/2010/main">
                 <a:effectLst>
                   <a:outerShdw blurRad="63500" dist="35921" dir="2700000" algn="ctr" rotWithShape="0">
                     <a:schemeClr val="bg2"/>
@@ -13731,14 +13731,14 @@
           <a:effectLst/>
           <a:extLst>
             <a:ext uri="{909E8E84-426E-40dd-AFC4-6F175D3DCCD1}">
-              <a14:hiddenFill xmlns:a14="http://schemas.microsoft.com/office/drawing/2010/main" xmlns="">
+              <a14:hiddenFill xmlns="" xmlns:a14="http://schemas.microsoft.com/office/drawing/2010/main">
                 <a:solidFill>
                   <a:schemeClr val="accent1"/>
                 </a:solidFill>
               </a14:hiddenFill>
             </a:ext>
             <a:ext uri="{AF507438-7753-43e0-B8FC-AC1667EBCBE1}">
-              <a14:hiddenEffects xmlns:a14="http://schemas.microsoft.com/office/drawing/2010/main" xmlns="">
+              <a14:hiddenEffects xmlns="" xmlns:a14="http://schemas.microsoft.com/office/drawing/2010/main">
                 <a:effectLst>
                   <a:outerShdw blurRad="63500" dist="35921" dir="2700000" algn="ctr" rotWithShape="0">
                     <a:schemeClr val="bg2"/>
@@ -14867,14 +14867,14 @@
           <a:noFill/>
           <a:extLst>
             <a:ext uri="{909E8E84-426E-40dd-AFC4-6F175D3DCCD1}">
-              <a14:hiddenFill xmlns="" xmlns:a14="http://schemas.microsoft.com/office/drawing/2010/main">
+              <a14:hiddenFill xmlns:a14="http://schemas.microsoft.com/office/drawing/2010/main" xmlns="">
                 <a:solidFill>
                   <a:srgbClr val="FFFFFF"/>
                 </a:solidFill>
               </a14:hiddenFill>
             </a:ext>
             <a:ext uri="{91240B29-F687-4f45-9708-019B960494DF}">
-              <a14:hiddenLine xmlns="" xmlns:a14="http://schemas.microsoft.com/office/drawing/2010/main" w="9525">
+              <a14:hiddenLine xmlns:a14="http://schemas.microsoft.com/office/drawing/2010/main" xmlns="" w="9525">
                 <a:solidFill>
                   <a:srgbClr val="000000"/>
                 </a:solidFill>
@@ -15302,7 +15302,7 @@
           </a:ln>
           <a:extLst>
             <a:ext uri="{91240B29-F687-4f45-9708-019B960494DF}">
-              <a14:hiddenLine xmlns:a14="http://schemas.microsoft.com/office/drawing/2010/main" xmlns="" w="12700" cap="sq">
+              <a14:hiddenLine xmlns="" xmlns:a14="http://schemas.microsoft.com/office/drawing/2010/main" w="12700" cap="sq">
                 <a:solidFill>
                   <a:srgbClr val="000000"/>
                 </a:solidFill>
@@ -15463,7 +15463,7 @@
           </a:ln>
           <a:extLst>
             <a:ext uri="{91240B29-F687-4f45-9708-019B960494DF}">
-              <a14:hiddenLine xmlns:a14="http://schemas.microsoft.com/office/drawing/2010/main" xmlns="" w="12700" cap="sq">
+              <a14:hiddenLine xmlns="" xmlns:a14="http://schemas.microsoft.com/office/drawing/2010/main" w="12700" cap="sq">
                 <a:solidFill>
                   <a:srgbClr val="000000"/>
                 </a:solidFill>
@@ -15624,7 +15624,7 @@
           </a:ln>
           <a:extLst>
             <a:ext uri="{91240B29-F687-4f45-9708-019B960494DF}">
-              <a14:hiddenLine xmlns:a14="http://schemas.microsoft.com/office/drawing/2010/main" xmlns="" w="12700" cap="sq">
+              <a14:hiddenLine xmlns="" xmlns:a14="http://schemas.microsoft.com/office/drawing/2010/main" w="12700" cap="sq">
                 <a:solidFill>
                   <a:srgbClr val="000000"/>
                 </a:solidFill>

</xml_diff>